<commit_message>
MAJ 23 statut etudiant et rangs
</commit_message>
<xml_diff>
--- a/presentation/Presentation_trajectoires_etudiants_ENSAI.pptx
+++ b/presentation/Presentation_trajectoires_etudiants_ENSAI.pptx
@@ -222,7 +222,7 @@
           <a:p>
             <a:fld id="{E7FCCED0-103C-4C10-8D72-99DD07E324A0}" type="datetimeFigureOut">
               <a:rPr lang="fr-FR" smtClean="0"/>
-              <a:t>08/06/2026</a:t>
+              <a:t>22/06/2026</a:t>
             </a:fld>
             <a:endParaRPr lang="fr-FR"/>
           </a:p>
@@ -387,7 +387,7 @@
           <a:p>
             <a:fld id="{EF258B95-F104-4A72-A4BF-C3A46957C253}" type="datetimeFigureOut">
               <a:rPr lang="fr-FR" smtClean="0"/>
-              <a:t>08/06/2026</a:t>
+              <a:t>22/06/2026</a:t>
             </a:fld>
             <a:endParaRPr lang="fr-FR"/>
           </a:p>
@@ -3690,7 +3690,7 @@
               <a:rPr lang="fr-FR" dirty="0">
                 <a:latin typeface="+mj-lt"/>
               </a:rPr>
-              <a:t>Premières analyses à partir des données d’amission, de Pamplemousse et de Moodle sur la période 2015-2025</a:t>
+              <a:t>Premières analyses à partir des données d’admission, de Pamplemousse et de Moodle sur la période 2015-2025</a:t>
             </a:r>
           </a:p>
         </p:txBody>
@@ -8386,7 +8386,7 @@
         </p:blipFill>
         <p:spPr>
           <a:xfrm>
-            <a:off x="4610424" y="1556503"/>
+            <a:off x="4662183" y="1588650"/>
             <a:ext cx="6965724" cy="3852013"/>
           </a:xfrm>
           <a:prstGeom prst="rect">
@@ -12697,12 +12697,8 @@
 </file>
 
 <file path=customXml/item2.xml><?xml version="1.0" encoding="utf-8"?>
-<p:properties xmlns:p="http://schemas.microsoft.com/office/2006/metadata/properties" xmlns:xsi="http://www.w3.org/2001/XMLSchema-instance" xmlns:pc="http://schemas.microsoft.com/office/infopath/2007/PartnerControls">
-  <documentManagement>
-    <Date1 xmlns="ec989fea-bb25-4413-a12c-f328b06a6537">2024-09-04T08:04:05+00:00</Date1>
-    <Mise_x0020_en_x0020_avant xmlns="ec989fea-bb25-4413-a12c-f328b06a6537">false</Mise_x0020_en_x0020_avant>
-  </documentManagement>
-</p:properties>
+<?mso-contentType ?>
+<SharedContentType xmlns="Microsoft.SharePoint.Taxonomy.ContentTypeSync" SourceId="a3fec588-6c6b-4406-8ca4-9ac9567ea887" ContentTypeId="0x0101003CC4B864CFCC5B4D9ACD432D285AC3BC" PreviousValue="false"/>
 </file>
 
 <file path=customXml/item3.xml><?xml version="1.0" encoding="utf-8"?>
@@ -12715,8 +12711,12 @@
 </file>
 
 <file path=customXml/item4.xml><?xml version="1.0" encoding="utf-8"?>
-<?mso-contentType ?>
-<SharedContentType xmlns="Microsoft.SharePoint.Taxonomy.ContentTypeSync" SourceId="a3fec588-6c6b-4406-8ca4-9ac9567ea887" ContentTypeId="0x0101003CC4B864CFCC5B4D9ACD432D285AC3BC" PreviousValue="false"/>
+<p:properties xmlns:p="http://schemas.microsoft.com/office/2006/metadata/properties" xmlns:xsi="http://www.w3.org/2001/XMLSchema-instance" xmlns:pc="http://schemas.microsoft.com/office/infopath/2007/PartnerControls">
+  <documentManagement>
+    <Date1 xmlns="ec989fea-bb25-4413-a12c-f328b06a6537">2024-09-04T08:04:05+00:00</Date1>
+    <Mise_x0020_en_x0020_avant xmlns="ec989fea-bb25-4413-a12c-f328b06a6537">false</Mise_x0020_en_x0020_avant>
+  </documentManagement>
+</p:properties>
 </file>
 
 <file path=customXml/itemProps1.xml><?xml version="1.0" encoding="utf-8"?>
@@ -12738,6 +12738,22 @@
 </file>
 
 <file path=customXml/itemProps2.xml><?xml version="1.0" encoding="utf-8"?>
+<ds:datastoreItem xmlns:ds="http://schemas.openxmlformats.org/officeDocument/2006/customXml" ds:itemID="{E5D901EE-349C-4207-96FC-2EDAA5B8F19A}">
+  <ds:schemaRefs>
+    <ds:schemaRef ds:uri="Microsoft.SharePoint.Taxonomy.ContentTypeSync"/>
+  </ds:schemaRefs>
+</ds:datastoreItem>
+</file>
+
+<file path=customXml/itemProps3.xml><?xml version="1.0" encoding="utf-8"?>
+<ds:datastoreItem xmlns:ds="http://schemas.openxmlformats.org/officeDocument/2006/customXml" ds:itemID="{192A3D37-6C49-4620-B2B6-76D5704EBC4C}">
+  <ds:schemaRefs>
+    <ds:schemaRef ds:uri="http://schemas.microsoft.com/sharepoint/v3/contenttype/forms"/>
+  </ds:schemaRefs>
+</ds:datastoreItem>
+</file>
+
+<file path=customXml/itemProps4.xml><?xml version="1.0" encoding="utf-8"?>
 <ds:datastoreItem xmlns:ds="http://schemas.openxmlformats.org/officeDocument/2006/customXml" ds:itemID="{F31EFE21-6212-40E3-9464-BEE2346D99CE}">
   <ds:schemaRefs>
     <ds:schemaRef ds:uri="http://schemas.microsoft.com/office/2006/documentManagement/types"/>
@@ -12751,20 +12767,4 @@
     <ds:schemaRef ds:uri="http://www.w3.org/XML/1998/namespace"/>
   </ds:schemaRefs>
 </ds:datastoreItem>
-</file>
-
-<file path=customXml/itemProps3.xml><?xml version="1.0" encoding="utf-8"?>
-<ds:datastoreItem xmlns:ds="http://schemas.openxmlformats.org/officeDocument/2006/customXml" ds:itemID="{192A3D37-6C49-4620-B2B6-76D5704EBC4C}">
-  <ds:schemaRefs>
-    <ds:schemaRef ds:uri="http://schemas.microsoft.com/sharepoint/v3/contenttype/forms"/>
-  </ds:schemaRefs>
-</ds:datastoreItem>
-</file>
-
-<file path=customXml/itemProps4.xml><?xml version="1.0" encoding="utf-8"?>
-<ds:datastoreItem xmlns:ds="http://schemas.openxmlformats.org/officeDocument/2006/customXml" ds:itemID="{E5D901EE-349C-4207-96FC-2EDAA5B8F19A}">
-  <ds:schemaRefs>
-    <ds:schemaRef ds:uri="Microsoft.SharePoint.Taxonomy.ContentTypeSync"/>
-  </ds:schemaRefs>
-</ds:datastoreItem>
 </file>
</xml_diff>